<commit_message>
chore: update SlideReact_template.pptx with new content
</commit_message>
<xml_diff>
--- a/public/SlideReact_template.pptx
+++ b/public/SlideReact_template.pptx
@@ -15,7 +15,7 @@
   <p:notesSz cx="6858000" cy="9144000"/>
   <p:embeddedFontLst>
     <p:embeddedFont>
-      <p:font typeface="Geomanist" panose="02000503000000020004" pitchFamily="50" charset="0"/>
+      <p:font typeface="Geomanist" panose="02000503000000020004" pitchFamily="2" charset="0"/>
       <p:regular r:id="rId8"/>
       <p:bold r:id="rId9"/>
     </p:embeddedFont>
@@ -3251,7 +3251,7 @@
             <a:effectLst/>
             <a:extLst>
               <a:ext uri="{C572A759-6A51-4108-AA02-DFA0A04FC94B}">
-                <ma14:wrappingTextBoxFlag xmlns:ma14="http://schemas.microsoft.com/office/mac/drawingml/2011/main" xmlns:a14="http://schemas.microsoft.com/office/drawing/2010/main" xmlns:m="http://schemas.openxmlformats.org/officeDocument/2006/math" xmlns="" val="1"/>
+                <ma14:wrappingTextBoxFlag xmlns="" xmlns:m="http://schemas.openxmlformats.org/officeDocument/2006/math" xmlns:a14="http://schemas.microsoft.com/office/drawing/2010/main" xmlns:ma14="http://schemas.microsoft.com/office/mac/drawingml/2011/main" val="1"/>
               </a:ext>
             </a:extLst>
           </p:spPr>
@@ -3458,7 +3458,7 @@
             </a:ln>
             <a:extLst>
               <a:ext uri="{C572A759-6A51-4108-AA02-DFA0A04FC94B}">
-                <ma14:wrappingTextBoxFlag xmlns:ma14="http://schemas.microsoft.com/office/mac/drawingml/2011/main" xmlns:a14="http://schemas.microsoft.com/office/drawing/2010/main" xmlns:m="http://schemas.openxmlformats.org/officeDocument/2006/math" xmlns="" val="1"/>
+                <ma14:wrappingTextBoxFlag xmlns="" xmlns:m="http://schemas.openxmlformats.org/officeDocument/2006/math" xmlns:a14="http://schemas.microsoft.com/office/drawing/2010/main" xmlns:ma14="http://schemas.microsoft.com/office/mac/drawingml/2011/main" val="1"/>
               </a:ext>
             </a:extLst>
           </p:spPr>
@@ -10912,7 +10912,7 @@
           <a:lstStyle/>
           <a:p>
             <a:r>
-              <a:rPr lang="fr-FR" b="1" cap="all" dirty="0"/>
+              <a:rPr lang="fr-FR" b="1" dirty="0"/>
               <a:t>Titre de la slide</a:t>
             </a:r>
             <a:endParaRPr lang="fr-FR" b="1" noProof="1">
@@ -13098,6 +13098,26 @@
 </file>
 
 <file path=customXml/item1.xml><?xml version="1.0" encoding="utf-8"?>
+<?mso-contentType ?>
+<FormTemplates xmlns="http://schemas.microsoft.com/sharepoint/v3/contenttype/forms">
+  <Display>DocumentLibraryForm</Display>
+  <Edit>DocumentLibraryForm</Edit>
+  <New>DocumentLibraryForm</New>
+</FormTemplates>
+</file>
+
+<file path=customXml/item2.xml><?xml version="1.0" encoding="utf-8"?>
+<p:properties xmlns:p="http://schemas.microsoft.com/office/2006/metadata/properties" xmlns:xsi="http://www.w3.org/2001/XMLSchema-instance" xmlns:pc="http://schemas.microsoft.com/office/infopath/2007/PartnerControls">
+  <documentManagement>
+    <TaxCatchAll xmlns="a8ec9101-e234-4bf3-85f2-17fe95c69024" xsi:nil="true"/>
+    <lcf76f155ced4ddcb4097134ff3c332f xmlns="10833e89-2023-4cf1-878e-22316438695a">
+      <Terms xmlns="http://schemas.microsoft.com/office/infopath/2007/PartnerControls"/>
+    </lcf76f155ced4ddcb4097134ff3c332f>
+  </documentManagement>
+</p:properties>
+</file>
+
+<file path=customXml/item3.xml><?xml version="1.0" encoding="utf-8"?>
 <ct:contentTypeSchema xmlns:ct="http://schemas.microsoft.com/office/2006/metadata/contentType" xmlns:ma="http://schemas.microsoft.com/office/2006/metadata/properties/metaAttributes" ct:_="" ma:_="" ma:contentTypeName="Document" ma:contentTypeID="0x010100337F3A349F173F4B857F02E46644D35F" ma:contentTypeVersion="16" ma:contentTypeDescription="Create a new document." ma:contentTypeScope="" ma:versionID="aa27624d0cfe0884392304e970b868f4">
   <xsd:schema xmlns:xsd="http://www.w3.org/2001/XMLSchema" xmlns:xs="http://www.w3.org/2001/XMLSchema" xmlns:p="http://schemas.microsoft.com/office/2006/metadata/properties" xmlns:ns2="10833e89-2023-4cf1-878e-22316438695a" xmlns:ns3="a8ec9101-e234-4bf3-85f2-17fe95c69024" targetNamespace="http://schemas.microsoft.com/office/2006/metadata/properties" ma:root="true" ma:fieldsID="4aa094190ffb5ae984a774d6011ca23b" ns2:_="" ns3:_="">
     <xsd:import namespace="10833e89-2023-4cf1-878e-22316438695a"/>
@@ -13338,41 +13358,10 @@
 </ct:contentTypeSchema>
 </file>
 
-<file path=customXml/item2.xml><?xml version="1.0" encoding="utf-8"?>
-<p:properties xmlns:p="http://schemas.microsoft.com/office/2006/metadata/properties" xmlns:xsi="http://www.w3.org/2001/XMLSchema-instance" xmlns:pc="http://schemas.microsoft.com/office/infopath/2007/PartnerControls">
-  <documentManagement>
-    <TaxCatchAll xmlns="a8ec9101-e234-4bf3-85f2-17fe95c69024" xsi:nil="true"/>
-    <lcf76f155ced4ddcb4097134ff3c332f xmlns="10833e89-2023-4cf1-878e-22316438695a">
-      <Terms xmlns="http://schemas.microsoft.com/office/infopath/2007/PartnerControls"/>
-    </lcf76f155ced4ddcb4097134ff3c332f>
-  </documentManagement>
-</p:properties>
-</file>
-
-<file path=customXml/item3.xml><?xml version="1.0" encoding="utf-8"?>
-<?mso-contentType ?>
-<FormTemplates xmlns="http://schemas.microsoft.com/sharepoint/v3/contenttype/forms">
-  <Display>DocumentLibraryForm</Display>
-  <Edit>DocumentLibraryForm</Edit>
-  <New>DocumentLibraryForm</New>
-</FormTemplates>
-</file>
-
 <file path=customXml/itemProps1.xml><?xml version="1.0" encoding="utf-8"?>
-<ds:datastoreItem xmlns:ds="http://schemas.openxmlformats.org/officeDocument/2006/customXml" ds:itemID="{6AE2A31F-E89E-4F7A-947C-3DBEC34C11CF}">
+<ds:datastoreItem xmlns:ds="http://schemas.openxmlformats.org/officeDocument/2006/customXml" ds:itemID="{23159F6D-0B30-46B7-AA48-83CF6A73058A}">
   <ds:schemaRefs>
-    <ds:schemaRef ds:uri="http://schemas.microsoft.com/office/2006/metadata/contentType"/>
-    <ds:schemaRef ds:uri="http://schemas.microsoft.com/office/2006/metadata/properties/metaAttributes"/>
-    <ds:schemaRef ds:uri="http://www.w3.org/2001/XMLSchema"/>
-    <ds:schemaRef ds:uri="http://schemas.microsoft.com/office/2006/metadata/properties"/>
-    <ds:schemaRef ds:uri="10833e89-2023-4cf1-878e-22316438695a"/>
-    <ds:schemaRef ds:uri="a8ec9101-e234-4bf3-85f2-17fe95c69024"/>
-    <ds:schemaRef ds:uri="http://schemas.microsoft.com/office/2006/documentManagement/types"/>
-    <ds:schemaRef ds:uri="http://schemas.microsoft.com/office/infopath/2007/PartnerControls"/>
-    <ds:schemaRef ds:uri="http://schemas.openxmlformats.org/package/2006/metadata/core-properties"/>
-    <ds:schemaRef ds:uri="http://purl.org/dc/elements/1.1/"/>
-    <ds:schemaRef ds:uri="http://purl.org/dc/terms/"/>
-    <ds:schemaRef ds:uri="http://schemas.microsoft.com/internal/obd"/>
+    <ds:schemaRef ds:uri="http://schemas.microsoft.com/sharepoint/v3/contenttype/forms"/>
   </ds:schemaRefs>
 </ds:datastoreItem>
 </file>
@@ -13395,9 +13384,20 @@
 </file>
 
 <file path=customXml/itemProps3.xml><?xml version="1.0" encoding="utf-8"?>
-<ds:datastoreItem xmlns:ds="http://schemas.openxmlformats.org/officeDocument/2006/customXml" ds:itemID="{23159F6D-0B30-46B7-AA48-83CF6A73058A}">
+<ds:datastoreItem xmlns:ds="http://schemas.openxmlformats.org/officeDocument/2006/customXml" ds:itemID="{6AE2A31F-E89E-4F7A-947C-3DBEC34C11CF}">
   <ds:schemaRefs>
-    <ds:schemaRef ds:uri="http://schemas.microsoft.com/sharepoint/v3/contenttype/forms"/>
+    <ds:schemaRef ds:uri="http://schemas.microsoft.com/office/2006/metadata/contentType"/>
+    <ds:schemaRef ds:uri="http://schemas.microsoft.com/office/2006/metadata/properties/metaAttributes"/>
+    <ds:schemaRef ds:uri="http://www.w3.org/2001/XMLSchema"/>
+    <ds:schemaRef ds:uri="http://schemas.microsoft.com/office/2006/metadata/properties"/>
+    <ds:schemaRef ds:uri="10833e89-2023-4cf1-878e-22316438695a"/>
+    <ds:schemaRef ds:uri="a8ec9101-e234-4bf3-85f2-17fe95c69024"/>
+    <ds:schemaRef ds:uri="http://schemas.microsoft.com/office/2006/documentManagement/types"/>
+    <ds:schemaRef ds:uri="http://schemas.microsoft.com/office/infopath/2007/PartnerControls"/>
+    <ds:schemaRef ds:uri="http://schemas.openxmlformats.org/package/2006/metadata/core-properties"/>
+    <ds:schemaRef ds:uri="http://purl.org/dc/elements/1.1/"/>
+    <ds:schemaRef ds:uri="http://purl.org/dc/terms/"/>
+    <ds:schemaRef ds:uri="http://schemas.microsoft.com/internal/obd"/>
   </ds:schemaRefs>
 </ds:datastoreItem>
 </file>
</xml_diff>